<commit_message>
Decks: render the book's notation in slide text
Co-Authored-By: Claude Opus 5.5 <noreply@anthropic.com>
Claude-Session: https://claude.ai/code/session_018eon9HRtnFa7qqQVV4TcNe
</commit_message>
<xml_diff>
--- a/downloads/DCT_V1_Ch01_Slides.pptx
+++ b/downloads/DCT_V1_Ch01_Slides.pptx
@@ -130,7 +130,7 @@
   <p:extLst>
     <p:ext uri="{521415D9-36F7-43E2-AB2F-B90AF26B5E84}">
       <p14:sectionLst xmlns:p14="http://schemas.microsoft.com/office/powerpoint/2010/main">
-        <p14:section name="Opening" id="{8163e489-e368-96ba-4557-e005bd3ef3dc}">
+        <p14:section name="Opening" id="{6585e946-8857-e996-a115-15e2ad9f0d33}">
           <p14:sldIdLst>
             <p14:sldId id="256"/>
             <p14:sldId id="257"/>
@@ -138,42 +138,42 @@
             <p14:sldId id="259"/>
           </p14:sldIdLst>
         </p14:section>
-        <p14:section name="1.1 The Transformation Question" id="{d55e2d48-5255-cae0-12d7-b4c17817909a}">
+        <p14:section name="1.1 The Transformation Question" id="{4da2828a-654a-1806-a7ec-7570d9784a9c}">
           <p14:sldIdLst>
             <p14:sldId id="260"/>
             <p14:sldId id="261"/>
           </p14:sldIdLst>
         </p14:section>
-        <p14:section name="1.2 How We Got Here" id="{c2fa21f3-88b4-42f3-3f67-ab0f7cb68938}">
+        <p14:section name="1.2 How We Got Here" id="{37796aad-81ad-98a8-8eac-d7e0b1f1b094}">
           <p14:sldIdLst>
             <p14:sldId id="262"/>
           </p14:sldIdLst>
         </p14:section>
-        <p14:section name="1.3 Why Existing Frameworks Fall Short" id="{c75a8062-0fd3-3894-ddea-14ad72f0317e}">
+        <p14:section name="1.3 Why Existing Frameworks Fall Short" id="{2a7143da-040b-5358-7c0a-f75d856fe196}">
           <p14:sldIdLst>
             <p14:sldId id="263"/>
           </p14:sldIdLst>
         </p14:section>
-        <p14:section name="1.4 What DCT Is" id="{094d2788-4fa1-c9c0-b1bc-ea56ee278f0e}">
+        <p14:section name="1.4 What DCT Is" id="{ed474585-e7c6-9c1b-f49f-9efaad170305}">
           <p14:sldIdLst>
             <p14:sldId id="264"/>
             <p14:sldId id="265"/>
             <p14:sldId id="266"/>
           </p14:sldIdLst>
         </p14:section>
-        <p14:section name="1.5 The DCT Map" id="{28d44d1d-e533-bdfa-46c7-c9ba7562e7ce}">
+        <p14:section name="1.5 The DCT Map" id="{8ced534d-b370-e82a-4c26-8ce297a5f74a}">
           <p14:sldIdLst>
             <p14:sldId id="267"/>
             <p14:sldId id="268"/>
             <p14:sldId id="269"/>
           </p14:sldIdLst>
         </p14:section>
-        <p14:section name="1.6 Learning with This Book" id="{33a58d12-c8ec-ea68-c329-09ac6850eea7}">
+        <p14:section name="1.6 Learning with This Book" id="{4fe64b9b-af4e-6b62-bf45-3c83906c753e}">
           <p14:sldIdLst>
             <p14:sldId id="270"/>
           </p14:sldIdLst>
         </p14:section>
-        <p14:section name="Worked Example 1.1" id="{f68d5555-498b-3070-58cd-90e858ea4f40}">
+        <p14:section name="Worked Example 1.1" id="{7186f96d-186f-ebe9-c635-46351a77f3ac}">
           <p14:sldIdLst>
             <p14:sldId id="271"/>
             <p14:sldId id="272"/>
@@ -182,12 +182,12 @@
             <p14:sldId id="275"/>
           </p14:sldIdLst>
         </p14:section>
-        <p14:section name="AXIOM Lab 1.1" id="{34d78902-244b-7b6b-073a-ea11a29aa39f}">
+        <p14:section name="AXIOM Lab 1.1" id="{5b7f7077-8932-6143-6194-83d669fb9b89}">
           <p14:sldIdLst>
             <p14:sldId id="276"/>
           </p14:sldIdLst>
         </p14:section>
-        <p14:section name="Close" id="{48fed312-09ba-26bb-58d4-af0f8c269f77}">
+        <p14:section name="Close" id="{c23292e3-cc58-c00c-7a4a-5db888babc7b}">
           <p14:sldIdLst>
             <p14:sldId id="277"/>
             <p14:sldId id="278"/>

</xml_diff>

<commit_message>
Companions: Ch 15 line cost at $1.65m, Ch 7 record law and Ch 8 trough wording; decks rebuilt
Co-Authored-By: Claude Opus 5.5 <noreply@anthropic.com>
Claude-Session: https://claude.ai/code/session_018eon9HRtnFa7qqQVV4TcNe
</commit_message>
<xml_diff>
--- a/downloads/DCT_V1_Ch01_Slides.pptx
+++ b/downloads/DCT_V1_Ch01_Slides.pptx
@@ -130,7 +130,7 @@
   <p:extLst>
     <p:ext uri="{521415D9-36F7-43E2-AB2F-B90AF26B5E84}">
       <p14:sectionLst xmlns:p14="http://schemas.microsoft.com/office/powerpoint/2010/main">
-        <p14:section name="Opening" id="{6585e946-8857-e996-a115-15e2ad9f0d33}">
+        <p14:section name="Opening" id="{43e785d7-1f25-a8d5-d95b-22d66c45ee0b}">
           <p14:sldIdLst>
             <p14:sldId id="256"/>
             <p14:sldId id="257"/>
@@ -138,42 +138,42 @@
             <p14:sldId id="259"/>
           </p14:sldIdLst>
         </p14:section>
-        <p14:section name="1.1 The Transformation Question" id="{4da2828a-654a-1806-a7ec-7570d9784a9c}">
+        <p14:section name="1.1 The Transformation Question" id="{ef3dfcdd-bdd5-202e-87d2-f8b892948815}">
           <p14:sldIdLst>
             <p14:sldId id="260"/>
             <p14:sldId id="261"/>
           </p14:sldIdLst>
         </p14:section>
-        <p14:section name="1.2 How We Got Here" id="{37796aad-81ad-98a8-8eac-d7e0b1f1b094}">
+        <p14:section name="1.2 How We Got Here" id="{750617e9-57e7-2963-c210-dd234973584b}">
           <p14:sldIdLst>
             <p14:sldId id="262"/>
           </p14:sldIdLst>
         </p14:section>
-        <p14:section name="1.3 Why Existing Frameworks Fall Short" id="{2a7143da-040b-5358-7c0a-f75d856fe196}">
+        <p14:section name="1.3 Why Existing Frameworks Fall Short" id="{5a2c16f5-12cc-af9b-cad6-1517ddf7d67c}">
           <p14:sldIdLst>
             <p14:sldId id="263"/>
           </p14:sldIdLst>
         </p14:section>
-        <p14:section name="1.4 What DCT Is" id="{ed474585-e7c6-9c1b-f49f-9efaad170305}">
+        <p14:section name="1.4 What DCT Is" id="{cbc8d737-659f-29e3-df65-3e62548a7f71}">
           <p14:sldIdLst>
             <p14:sldId id="264"/>
             <p14:sldId id="265"/>
             <p14:sldId id="266"/>
           </p14:sldIdLst>
         </p14:section>
-        <p14:section name="1.5 The DCT Map" id="{8ced534d-b370-e82a-4c26-8ce297a5f74a}">
+        <p14:section name="1.5 The DCT Map" id="{28c1b099-8825-973e-e66c-4b6b39d19b1c}">
           <p14:sldIdLst>
             <p14:sldId id="267"/>
             <p14:sldId id="268"/>
             <p14:sldId id="269"/>
           </p14:sldIdLst>
         </p14:section>
-        <p14:section name="1.6 Learning with This Book" id="{4fe64b9b-af4e-6b62-bf45-3c83906c753e}">
+        <p14:section name="1.6 Learning with This Book" id="{f35b2d34-bfce-10d0-4d4b-03c96e7c5bf7}">
           <p14:sldIdLst>
             <p14:sldId id="270"/>
           </p14:sldIdLst>
         </p14:section>
-        <p14:section name="Worked Example 1.1" id="{7186f96d-186f-ebe9-c635-46351a77f3ac}">
+        <p14:section name="Worked Example 1.1" id="{83e7d7f0-dc2e-ea0b-9ace-ed084870f094}">
           <p14:sldIdLst>
             <p14:sldId id="271"/>
             <p14:sldId id="272"/>
@@ -182,12 +182,12 @@
             <p14:sldId id="275"/>
           </p14:sldIdLst>
         </p14:section>
-        <p14:section name="AXIOM Lab 1.1" id="{5b7f7077-8932-6143-6194-83d669fb9b89}">
+        <p14:section name="AXIOM Lab 1.1" id="{9cf6b65a-cba7-d588-b3ac-96dfa277d930}">
           <p14:sldIdLst>
             <p14:sldId id="276"/>
           </p14:sldIdLst>
         </p14:section>
-        <p14:section name="Close" id="{c23292e3-cc58-c00c-7a4a-5db888babc7b}">
+        <p14:section name="Close" id="{d494857d-9b75-538e-49d6-0b3d53d3f506}">
           <p14:sldIdLst>
             <p14:sldId id="277"/>
             <p14:sldId id="278"/>

</xml_diff>